<commit_message>
S10: presentacion corregida (25 endpoints, limitaciones y mejoras, IA nombrada, roles y KPIs alineados al manual)
Co-Authored-By: Claude Opus 5.5 <noreply@anthropic.com>
Claude-Session: https://claude.ai/code/session_01B4tdcRGH7JDNA5YFxF39L6
</commit_message>
<xml_diff>
--- a/docs/presentacion/Defensa_S10_Helaspi.pptx
+++ b/docs/presentacion/Defensa_S10_Helaspi.pptx
@@ -19,6 +19,7 @@
     <p:sldId id="267" r:id="rId13"/>
     <p:sldId id="268" r:id="rId14"/>
     <p:sldId id="269" r:id="rId15"/>
+    <p:sldId id="272" r:id="rId23"/>
     <p:sldId id="270" r:id="rId16"/>
     <p:sldId id="271" r:id="rId17"/>
   </p:sldIdLst>
@@ -3713,7 +3714,7 @@
                 <a:ea typeface="Cambria" pitchFamily="34" charset="-122"/>
                 <a:cs typeface="Cambria" pitchFamily="34" charset="-120"/>
               </a:rPr>
-              <a:t>Datos de prueba limpios</a:t>
+              <a:t>Filtro de proveedores inactivos</a:t>
             </a:r>
             <a:endParaRPr lang="en-US" sz="1400" dirty="0"/>
           </a:p>
@@ -3752,7 +3753,7 @@
                 <a:ea typeface="Calibri" pitchFamily="34" charset="-122"/>
                 <a:cs typeface="Calibri" pitchFamily="34" charset="-120"/>
               </a:rPr>
-              <a:t>La consulta de "MP por proveedor" filtra proveedores activos, para que los que se dieron de baja en las pruebas no ensucien el tablero.</a:t>
+              <a:t>La consulta de "MP por proveedor" solo cuenta proveedores activos: los dados de baja no aparecen en el gráfico.</a:t>
             </a:r>
             <a:endParaRPr lang="en-US" sz="1250" dirty="0"/>
           </a:p>
@@ -4246,7 +4247,7 @@
                 <a:ea typeface="Cambria" pitchFamily="34" charset="-122"/>
                 <a:cs typeface="Cambria" pitchFamily="34" charset="-120"/>
               </a:rPr>
-              <a:t>19</a:t>
+              <a:t>25</a:t>
             </a:r>
             <a:endParaRPr lang="en-US" sz="4400" dirty="0"/>
           </a:p>
@@ -5283,7 +5284,7 @@
                 <a:ea typeface="Calibri" pitchFamily="34" charset="-122"/>
                 <a:cs typeface="Calibri" pitchFamily="34" charset="-120"/>
               </a:rPr>
-              <a:t>Se usó asistencia de IA como herramienta de desarrollo, con registro de cada decisión en bitácoras — una por semana de trabajo.</a:t>
+              <a:t>Se usó Claude (Anthropic) como asistente de desarrollo, con registro de cada decisión en bitácoras — una por semana de trabajo.</a:t>
             </a:r>
             <a:endParaRPr lang="en-US" sz="1400" dirty="0"/>
           </a:p>
@@ -6492,7 +6493,7 @@
                 <a:ea typeface="Calibri" pitchFamily="34" charset="-122"/>
                 <a:cs typeface="Calibri" pitchFamily="34" charset="-120"/>
               </a:rPr>
-              <a:t>Queda como mejora futura: lector de QR integrado en la app (hoy depende de la cámara del celular).</a:t>
+              <a:t>Las pruebas automatizadas encontraron errores que a simple vista no se veían (H1–H6): probar es parte de desarrollar, no un paso final.</a:t>
             </a:r>
             <a:endParaRPr lang="en-US" sz="1250" dirty="0"/>
           </a:p>
@@ -6661,6 +6662,728 @@
 </p:sld>
 </file>
 
+<file path=ppt/slides/slide17.xml><?xml version="1.0" encoding="utf-8"?>
+<p:sld xmlns:a="http://schemas.openxmlformats.org/drawingml/2006/main" xmlns:r="http://schemas.openxmlformats.org/officeDocument/2006/relationships" xmlns:p="http://schemas.openxmlformats.org/presentationml/2006/main">
+  <p:cSld name="Slide 15">
+    <p:spTree>
+      <p:nvGrpSpPr>
+        <p:cNvPr id="1" name=""/>
+        <p:cNvGrpSpPr/>
+        <p:nvPr/>
+      </p:nvGrpSpPr>
+      <p:grpSpPr>
+        <a:xfrm>
+          <a:off x="0" y="0"/>
+          <a:ext cx="0" cy="0"/>
+          <a:chOff x="0" y="0"/>
+          <a:chExt cx="0" cy="0"/>
+        </a:xfrm>
+      </p:grpSpPr>
+      <p:sp>
+        <p:nvSpPr>
+          <p:cNvPr id="2" name="Text 0"/>
+          <p:cNvSpPr/>
+          <p:nvPr>
+            <p:ph idx="100" type="title" hasCustomPrompt="1"/>
+          </p:nvPr>
+        </p:nvSpPr>
+        <p:spPr>
+          <a:xfrm>
+            <a:off x="640080" y="457200"/>
+            <a:ext cx="10881360" cy="822960"/>
+          </a:xfrm>
+          <a:prstGeom prst="rect">
+            <a:avLst/>
+          </a:prstGeom>
+          <a:noFill/>
+          <a:ln/>
+        </p:spPr>
+        <p:txBody>
+          <a:bodyPr wrap="square" rtlCol="0"/>
+          <a:lstStyle/>
+          <a:p>
+            <a:pPr algn="l" indent="0" marL="0">
+              <a:buNone/>
+            </a:pPr>
+            <a:r>
+              <a:rPr lang="en-US" sz="3000" b="1" dirty="0">
+                <a:solidFill>
+                  <a:schemeClr val="tx1"/>
+                </a:solidFill>
+                <a:latin typeface="Cambria" pitchFamily="34" charset="0"/>
+                <a:ea typeface="Cambria" pitchFamily="34" charset="-122"/>
+                <a:cs typeface="Cambria" pitchFamily="34" charset="-120"/>
+              </a:rPr>
+              <a:t>Limitaciones y mejoras futuras</a:t>
+            </a:r>
+            <a:endParaRPr lang="en-US" sz="3000" dirty="0"/>
+          </a:p>
+        </p:txBody>
+      </p:sp>
+      <p:sp>
+        <p:nvSpPr>
+          <p:cNvPr id="3" name="Shape 1"/>
+          <p:cNvSpPr/>
+          <p:nvPr/>
+        </p:nvSpPr>
+        <p:spPr>
+          <a:xfrm>
+            <a:off x="640080" y="1554480"/>
+            <a:ext cx="5212080" cy="4480560"/>
+          </a:xfrm>
+          <a:prstGeom prst="roundRect">
+            <a:avLst>
+              <a:gd name="adj" fmla="val 2449"/>
+            </a:avLst>
+          </a:prstGeom>
+          <a:solidFill>
+            <a:srgbClr val="FFFFFF"/>
+          </a:solidFill>
+          <a:ln/>
+          <a:effectLst>
+            <a:outerShdw sx="100000" sy="100000" kx="0" ky="0" algn="bl" rotWithShape="0" blurRad="101600" dist="38100" dir="5400000">
+              <a:srgbClr val="1C2B40">
+                <a:alpha val="18000"/>
+              </a:srgbClr>
+            </a:outerShdw>
+          </a:effectLst>
+        </p:spPr>
+      </p:sp>
+      <p:sp>
+        <p:nvSpPr>
+          <p:cNvPr id="4" name="Text 2"/>
+          <p:cNvSpPr txBox="1"/>
+          <p:nvPr/>
+        </p:nvSpPr>
+        <p:spPr>
+          <a:xfrm>
+            <a:off x="960120" y="1783080"/>
+            <a:ext cx="4572000" cy="365760"/>
+          </a:xfrm>
+          <a:prstGeom prst="rect">
+            <a:avLst/>
+          </a:prstGeom>
+          <a:noFill/>
+          <a:ln/>
+        </p:spPr>
+        <p:txBody>
+          <a:bodyPr wrap="square" lIns="0" tIns="0" rIns="0" bIns="0" rtlCol="0" anchor="ctr"/>
+          <a:lstStyle/>
+          <a:p>
+            <a:pPr indent="0" marL="0">
+              <a:buNone/>
+            </a:pPr>
+            <a:r>
+              <a:rPr lang="en-US" sz="1500" b="1" dirty="0">
+                <a:solidFill>
+                  <a:srgbClr val="24344D"/>
+                </a:solidFill>
+                <a:latin typeface="Cambria" pitchFamily="34" charset="0"/>
+                <a:ea typeface="Cambria" pitchFamily="34" charset="-122"/>
+                <a:cs typeface="Cambria" pitchFamily="34" charset="-120"/>
+              </a:rPr>
+              <a:t>Limitaciones conocidas</a:t>
+            </a:r>
+            <a:endParaRPr lang="en-US" sz="1500" dirty="0"/>
+          </a:p>
+        </p:txBody>
+      </p:sp>
+      <p:sp>
+        <p:nvSpPr>
+          <p:cNvPr id="5" name="Shape 3"/>
+          <p:cNvSpPr/>
+          <p:nvPr/>
+        </p:nvSpPr>
+        <p:spPr>
+          <a:xfrm>
+            <a:off x="960120" y="2542032"/>
+            <a:ext cx="82296" cy="82296"/>
+          </a:xfrm>
+          <a:prstGeom prst="ellipse">
+            <a:avLst/>
+          </a:prstGeom>
+          <a:solidFill>
+            <a:srgbClr val="6F9BD1"/>
+          </a:solidFill>
+          <a:ln/>
+        </p:spPr>
+      </p:sp>
+      <p:sp>
+        <p:nvSpPr>
+          <p:cNvPr id="6" name="Text 4"/>
+          <p:cNvSpPr txBox="1"/>
+          <p:nvPr/>
+        </p:nvSpPr>
+        <p:spPr>
+          <a:xfrm>
+            <a:off x="1188720" y="2194560"/>
+            <a:ext cx="4480560" cy="777240"/>
+          </a:xfrm>
+          <a:prstGeom prst="rect">
+            <a:avLst/>
+          </a:prstGeom>
+          <a:noFill/>
+          <a:ln/>
+        </p:spPr>
+        <p:txBody>
+          <a:bodyPr wrap="square" lIns="0" tIns="0" rIns="0" bIns="0" rtlCol="0" anchor="ctr"/>
+          <a:lstStyle/>
+          <a:p>
+            <a:pPr indent="0" marL="0">
+              <a:buNone/>
+            </a:pPr>
+            <a:r>
+              <a:rPr lang="en-US" sz="1250" dirty="0">
+                <a:solidFill>
+                  <a:srgbClr val="1C2B40"/>
+                </a:solidFill>
+                <a:latin typeface="Calibri" pitchFamily="34" charset="0"/>
+                <a:ea typeface="Calibri" pitchFamily="34" charset="-122"/>
+                <a:cs typeface="Calibri" pitchFamily="34" charset="-120"/>
+              </a:rPr>
+              <a:t>La URL del QR incluye la IP de la PC: si cambia la red, las etiquetas ya impresas dejan de abrir.</a:t>
+            </a:r>
+            <a:endParaRPr lang="en-US" sz="1250" dirty="0"/>
+          </a:p>
+        </p:txBody>
+      </p:sp>
+      <p:sp>
+        <p:nvSpPr>
+          <p:cNvPr id="7" name="Shape 5"/>
+          <p:cNvSpPr/>
+          <p:nvPr/>
+        </p:nvSpPr>
+        <p:spPr>
+          <a:xfrm>
+            <a:off x="960120" y="3410712"/>
+            <a:ext cx="82296" cy="82296"/>
+          </a:xfrm>
+          <a:prstGeom prst="ellipse">
+            <a:avLst/>
+          </a:prstGeom>
+          <a:solidFill>
+            <a:srgbClr val="6F9BD1"/>
+          </a:solidFill>
+          <a:ln/>
+        </p:spPr>
+      </p:sp>
+      <p:sp>
+        <p:nvSpPr>
+          <p:cNvPr id="8" name="Text 6"/>
+          <p:cNvSpPr txBox="1"/>
+          <p:nvPr/>
+        </p:nvSpPr>
+        <p:spPr>
+          <a:xfrm>
+            <a:off x="1188720" y="3063240"/>
+            <a:ext cx="4480560" cy="777240"/>
+          </a:xfrm>
+          <a:prstGeom prst="rect">
+            <a:avLst/>
+          </a:prstGeom>
+          <a:noFill/>
+          <a:ln/>
+        </p:spPr>
+        <p:txBody>
+          <a:bodyPr wrap="square" lIns="0" tIns="0" rIns="0" bIns="0" rtlCol="0" anchor="ctr"/>
+          <a:lstStyle/>
+          <a:p>
+            <a:pPr indent="0" marL="0">
+              <a:buNone/>
+            </a:pPr>
+            <a:r>
+              <a:rPr lang="en-US" sz="1250" dirty="0">
+                <a:solidFill>
+                  <a:srgbClr val="1C2B40"/>
+                </a:solidFill>
+                <a:latin typeface="Calibri" pitchFamily="34" charset="0"/>
+                <a:ea typeface="Calibri" pitchFamily="34" charset="-122"/>
+                <a:cs typeface="Calibri" pitchFamily="34" charset="-120"/>
+              </a:rPr>
+              <a:t>Para consultar hace falta un celular en la misma red y con sesión iniciada (rutas protegidas por JWT).</a:t>
+            </a:r>
+            <a:endParaRPr lang="en-US" sz="1250" dirty="0"/>
+          </a:p>
+        </p:txBody>
+      </p:sp>
+      <p:sp>
+        <p:nvSpPr>
+          <p:cNvPr id="9" name="Shape 7"/>
+          <p:cNvSpPr/>
+          <p:nvPr/>
+        </p:nvSpPr>
+        <p:spPr>
+          <a:xfrm>
+            <a:off x="960120" y="4279392"/>
+            <a:ext cx="82296" cy="82296"/>
+          </a:xfrm>
+          <a:prstGeom prst="ellipse">
+            <a:avLst/>
+          </a:prstGeom>
+          <a:solidFill>
+            <a:srgbClr val="6F9BD1"/>
+          </a:solidFill>
+          <a:ln/>
+        </p:spPr>
+      </p:sp>
+      <p:sp>
+        <p:nvSpPr>
+          <p:cNvPr id="10" name="Text 8"/>
+          <p:cNvSpPr txBox="1"/>
+          <p:nvPr/>
+        </p:nvSpPr>
+        <p:spPr>
+          <a:xfrm>
+            <a:off x="1188720" y="3931920"/>
+            <a:ext cx="4480560" cy="777240"/>
+          </a:xfrm>
+          <a:prstGeom prst="rect">
+            <a:avLst/>
+          </a:prstGeom>
+          <a:noFill/>
+          <a:ln/>
+        </p:spPr>
+        <p:txBody>
+          <a:bodyPr wrap="square" lIns="0" tIns="0" rIns="0" bIns="0" rtlCol="0" anchor="ctr"/>
+          <a:lstStyle/>
+          <a:p>
+            <a:pPr indent="0" marL="0">
+              <a:buNone/>
+            </a:pPr>
+            <a:r>
+              <a:rPr lang="en-US" sz="1250" dirty="0">
+                <a:solidFill>
+                  <a:srgbClr val="1C2B40"/>
+                </a:solidFill>
+                <a:latin typeface="Calibri" pitchFamily="34" charset="0"/>
+                <a:ea typeface="Calibri" pitchFamily="34" charset="-122"/>
+                <a:cs typeface="Calibri" pitchFamily="34" charset="-120"/>
+              </a:rPr>
+              <a:t>La gestión de proveedores existe en la API, pero no tiene pantalla en esta versión.</a:t>
+            </a:r>
+            <a:endParaRPr lang="en-US" sz="1250" dirty="0"/>
+          </a:p>
+        </p:txBody>
+      </p:sp>
+      <p:sp>
+        <p:nvSpPr>
+          <p:cNvPr id="26" name="Shape 26"/>
+          <p:cNvSpPr/>
+          <p:nvPr/>
+        </p:nvSpPr>
+        <p:spPr>
+          <a:xfrm>
+            <a:off x="960120" y="5148072"/>
+            <a:ext cx="82296" cy="82296"/>
+          </a:xfrm>
+          <a:prstGeom prst="ellipse">
+            <a:avLst/>
+          </a:prstGeom>
+          <a:solidFill>
+            <a:srgbClr val="6F9BD1"/>
+          </a:solidFill>
+          <a:ln/>
+        </p:spPr>
+      </p:sp>
+      <p:sp>
+        <p:nvSpPr>
+          <p:cNvPr id="27" name="Text 27"/>
+          <p:cNvSpPr txBox="1"/>
+          <p:nvPr/>
+        </p:nvSpPr>
+        <p:spPr>
+          <a:xfrm>
+            <a:off x="1188720" y="4800600"/>
+            <a:ext cx="4480560" cy="777240"/>
+          </a:xfrm>
+          <a:prstGeom prst="rect">
+            <a:avLst/>
+          </a:prstGeom>
+          <a:noFill/>
+          <a:ln/>
+        </p:spPr>
+        <p:txBody>
+          <a:bodyPr wrap="square" lIns="0" tIns="0" rIns="0" bIns="0" rtlCol="0" anchor="ctr"/>
+          <a:lstStyle/>
+          <a:p>
+            <a:pPr indent="0" marL="0">
+              <a:buNone/>
+            </a:pPr>
+            <a:r>
+              <a:rPr lang="en-US" sz="1250" dirty="0">
+                <a:solidFill>
+                  <a:srgbClr val="1C2B40"/>
+                </a:solidFill>
+                <a:latin typeface="Calibri" pitchFamily="34" charset="0"/>
+                <a:ea typeface="Calibri" pitchFamily="34" charset="-122"/>
+                <a:cs typeface="Calibri" pitchFamily="34" charset="-120"/>
+              </a:rPr>
+              <a:t>"No darse de baja a sí mismo" se controla solo en el frontend, y la pantalla de Usuarios no tiene pruebas automatizadas.</a:t>
+            </a:r>
+            <a:endParaRPr lang="en-US" sz="1250" dirty="0"/>
+          </a:p>
+        </p:txBody>
+      </p:sp>
+      <p:sp>
+        <p:nvSpPr>
+          <p:cNvPr id="11" name="Shape 9"/>
+          <p:cNvSpPr/>
+          <p:nvPr/>
+        </p:nvSpPr>
+        <p:spPr>
+          <a:xfrm>
+            <a:off x="6126480" y="1554480"/>
+            <a:ext cx="5394960" cy="4480560"/>
+          </a:xfrm>
+          <a:prstGeom prst="roundRect">
+            <a:avLst>
+              <a:gd name="adj" fmla="val 2449"/>
+            </a:avLst>
+          </a:prstGeom>
+          <a:solidFill>
+            <a:srgbClr val="1C2B40"/>
+          </a:solidFill>
+          <a:ln/>
+          <a:effectLst>
+            <a:outerShdw sx="100000" sy="100000" kx="0" ky="0" algn="bl" rotWithShape="0" blurRad="101600" dist="38100" dir="5400000">
+              <a:srgbClr val="1C2B40">
+                <a:alpha val="18000"/>
+              </a:srgbClr>
+            </a:outerShdw>
+          </a:effectLst>
+        </p:spPr>
+      </p:sp>
+      <p:sp>
+        <p:nvSpPr>
+          <p:cNvPr id="12" name="Text 10"/>
+          <p:cNvSpPr txBox="1"/>
+          <p:nvPr/>
+        </p:nvSpPr>
+        <p:spPr>
+          <a:xfrm>
+            <a:off x="6446520" y="1783080"/>
+            <a:ext cx="4754880" cy="365760"/>
+          </a:xfrm>
+          <a:prstGeom prst="rect">
+            <a:avLst/>
+          </a:prstGeom>
+          <a:noFill/>
+          <a:ln/>
+        </p:spPr>
+        <p:txBody>
+          <a:bodyPr wrap="square" lIns="0" tIns="0" rIns="0" bIns="0" rtlCol="0" anchor="ctr"/>
+          <a:lstStyle/>
+          <a:p>
+            <a:pPr indent="0" marL="0">
+              <a:buNone/>
+            </a:pPr>
+            <a:r>
+              <a:rPr lang="en-US" sz="1500" b="1" dirty="0">
+                <a:solidFill>
+                  <a:srgbClr val="F2A541"/>
+                </a:solidFill>
+                <a:latin typeface="Cambria" pitchFamily="34" charset="0"/>
+                <a:ea typeface="Cambria" pitchFamily="34" charset="-122"/>
+                <a:cs typeface="Cambria" pitchFamily="34" charset="-120"/>
+              </a:rPr>
+              <a:t>Mejoras futuras</a:t>
+            </a:r>
+            <a:endParaRPr lang="en-US" sz="1500" dirty="0"/>
+          </a:p>
+        </p:txBody>
+      </p:sp>
+      <p:sp>
+        <p:nvSpPr>
+          <p:cNvPr id="13" name="Shape 11"/>
+          <p:cNvSpPr/>
+          <p:nvPr/>
+        </p:nvSpPr>
+        <p:spPr>
+          <a:xfrm>
+            <a:off x="6446520" y="2542032"/>
+            <a:ext cx="82296" cy="82296"/>
+          </a:xfrm>
+          <a:prstGeom prst="ellipse">
+            <a:avLst/>
+          </a:prstGeom>
+          <a:solidFill>
+            <a:srgbClr val="F2A541"/>
+          </a:solidFill>
+          <a:ln/>
+        </p:spPr>
+      </p:sp>
+      <p:sp>
+        <p:nvSpPr>
+          <p:cNvPr id="14" name="Text 12"/>
+          <p:cNvSpPr txBox="1"/>
+          <p:nvPr/>
+        </p:nvSpPr>
+        <p:spPr>
+          <a:xfrm>
+            <a:off x="6675120" y="2194560"/>
+            <a:ext cx="4663440" cy="777240"/>
+          </a:xfrm>
+          <a:prstGeom prst="rect">
+            <a:avLst/>
+          </a:prstGeom>
+          <a:noFill/>
+          <a:ln/>
+        </p:spPr>
+        <p:txBody>
+          <a:bodyPr wrap="square" lIns="0" tIns="0" rIns="0" bIns="0" rtlCol="0" anchor="ctr"/>
+          <a:lstStyle/>
+          <a:p>
+            <a:pPr indent="0" marL="0">
+              <a:buNone/>
+            </a:pPr>
+            <a:r>
+              <a:rPr lang="en-US" sz="1250" dirty="0">
+                <a:solidFill>
+                  <a:srgbClr val="E4E9F2"/>
+                </a:solidFill>
+                <a:latin typeface="Calibri" pitchFamily="34" charset="0"/>
+                <a:ea typeface="Calibri" pitchFamily="34" charset="-122"/>
+                <a:cs typeface="Calibri" pitchFamily="34" charset="-120"/>
+              </a:rPr>
+              <a:t>Publicar el servidor con dominio o IP fija, para que las etiquetas no dependan de la red local.</a:t>
+            </a:r>
+            <a:endParaRPr lang="en-US" sz="1250" dirty="0"/>
+          </a:p>
+        </p:txBody>
+      </p:sp>
+      <p:sp>
+        <p:nvSpPr>
+          <p:cNvPr id="15" name="Shape 13"/>
+          <p:cNvSpPr/>
+          <p:nvPr/>
+        </p:nvSpPr>
+        <p:spPr>
+          <a:xfrm>
+            <a:off x="6446520" y="3410712"/>
+            <a:ext cx="82296" cy="82296"/>
+          </a:xfrm>
+          <a:prstGeom prst="ellipse">
+            <a:avLst/>
+          </a:prstGeom>
+          <a:solidFill>
+            <a:srgbClr val="F2A541"/>
+          </a:solidFill>
+          <a:ln/>
+        </p:spPr>
+      </p:sp>
+      <p:sp>
+        <p:nvSpPr>
+          <p:cNvPr id="16" name="Text 14"/>
+          <p:cNvSpPr txBox="1"/>
+          <p:nvPr/>
+        </p:nvSpPr>
+        <p:spPr>
+          <a:xfrm>
+            <a:off x="6675120" y="3063240"/>
+            <a:ext cx="4663440" cy="777240"/>
+          </a:xfrm>
+          <a:prstGeom prst="rect">
+            <a:avLst/>
+          </a:prstGeom>
+          <a:noFill/>
+          <a:ln/>
+        </p:spPr>
+        <p:txBody>
+          <a:bodyPr wrap="square" lIns="0" tIns="0" rIns="0" bIns="0" rtlCol="0" anchor="ctr"/>
+          <a:lstStyle/>
+          <a:p>
+            <a:pPr indent="0" marL="0">
+              <a:buNone/>
+            </a:pPr>
+            <a:r>
+              <a:rPr lang="en-US" sz="1250" dirty="0">
+                <a:solidFill>
+                  <a:srgbClr val="E4E9F2"/>
+                </a:solidFill>
+                <a:latin typeface="Calibri" pitchFamily="34" charset="0"/>
+                <a:ea typeface="Calibri" pitchFamily="34" charset="-122"/>
+                <a:cs typeface="Calibri" pitchFamily="34" charset="-120"/>
+              </a:rPr>
+              <a:t>Lector de QR integrado en la app (hoy se usa la cámara del celular).</a:t>
+            </a:r>
+            <a:endParaRPr lang="en-US" sz="1250" dirty="0"/>
+          </a:p>
+        </p:txBody>
+      </p:sp>
+      <p:sp>
+        <p:nvSpPr>
+          <p:cNvPr id="17" name="Shape 15"/>
+          <p:cNvSpPr/>
+          <p:nvPr/>
+        </p:nvSpPr>
+        <p:spPr>
+          <a:xfrm>
+            <a:off x="6446520" y="4279392"/>
+            <a:ext cx="82296" cy="82296"/>
+          </a:xfrm>
+          <a:prstGeom prst="ellipse">
+            <a:avLst/>
+          </a:prstGeom>
+          <a:solidFill>
+            <a:srgbClr val="F2A541"/>
+          </a:solidFill>
+          <a:ln/>
+        </p:spPr>
+      </p:sp>
+      <p:sp>
+        <p:nvSpPr>
+          <p:cNvPr id="18" name="Text 16"/>
+          <p:cNvSpPr txBox="1"/>
+          <p:nvPr/>
+        </p:nvSpPr>
+        <p:spPr>
+          <a:xfrm>
+            <a:off x="6675120" y="3931920"/>
+            <a:ext cx="4663440" cy="777240"/>
+          </a:xfrm>
+          <a:prstGeom prst="rect">
+            <a:avLst/>
+          </a:prstGeom>
+          <a:noFill/>
+          <a:ln/>
+        </p:spPr>
+        <p:txBody>
+          <a:bodyPr wrap="square" lIns="0" tIns="0" rIns="0" bIns="0" rtlCol="0" anchor="ctr"/>
+          <a:lstStyle/>
+          <a:p>
+            <a:pPr indent="0" marL="0">
+              <a:buNone/>
+            </a:pPr>
+            <a:r>
+              <a:rPr lang="en-US" sz="1250" dirty="0">
+                <a:solidFill>
+                  <a:srgbClr val="E4E9F2"/>
+                </a:solidFill>
+                <a:latin typeface="Calibri" pitchFamily="34" charset="0"/>
+                <a:ea typeface="Calibri" pitchFamily="34" charset="-122"/>
+                <a:cs typeface="Calibri" pitchFamily="34" charset="-120"/>
+              </a:rPr>
+              <a:t>Pantalla de gestión de proveedores para el rol Calidad.</a:t>
+            </a:r>
+            <a:endParaRPr lang="en-US" sz="1250" dirty="0"/>
+          </a:p>
+        </p:txBody>
+      </p:sp>
+      <p:sp>
+        <p:nvSpPr>
+          <p:cNvPr id="28" name="Shape 28"/>
+          <p:cNvSpPr/>
+          <p:nvPr/>
+        </p:nvSpPr>
+        <p:spPr>
+          <a:xfrm>
+            <a:off x="6446520" y="5148072"/>
+            <a:ext cx="82296" cy="82296"/>
+          </a:xfrm>
+          <a:prstGeom prst="ellipse">
+            <a:avLst/>
+          </a:prstGeom>
+          <a:solidFill>
+            <a:srgbClr val="F2A541"/>
+          </a:solidFill>
+          <a:ln/>
+        </p:spPr>
+      </p:sp>
+      <p:sp>
+        <p:nvSpPr>
+          <p:cNvPr id="29" name="Text 29"/>
+          <p:cNvSpPr txBox="1"/>
+          <p:nvPr/>
+        </p:nvSpPr>
+        <p:spPr>
+          <a:xfrm>
+            <a:off x="6675120" y="4800600"/>
+            <a:ext cx="4663440" cy="777240"/>
+          </a:xfrm>
+          <a:prstGeom prst="rect">
+            <a:avLst/>
+          </a:prstGeom>
+          <a:noFill/>
+          <a:ln/>
+        </p:spPr>
+        <p:txBody>
+          <a:bodyPr wrap="square" lIns="0" tIns="0" rIns="0" bIns="0" rtlCol="0" anchor="ctr"/>
+          <a:lstStyle/>
+          <a:p>
+            <a:pPr indent="0" marL="0">
+              <a:buNone/>
+            </a:pPr>
+            <a:r>
+              <a:rPr lang="en-US" sz="1250" dirty="0">
+                <a:solidFill>
+                  <a:srgbClr val="E4E9F2"/>
+                </a:solidFill>
+                <a:latin typeface="Calibri" pitchFamily="34" charset="0"/>
+                <a:ea typeface="Calibri" pitchFamily="34" charset="-122"/>
+                <a:cs typeface="Calibri" pitchFamily="34" charset="-120"/>
+              </a:rPr>
+              <a:t>Validar la auto-baja en el backend y sumar la gestión de usuarios a Newman y al escenario E2E.</a:t>
+            </a:r>
+            <a:endParaRPr lang="en-US" sz="1250" dirty="0"/>
+          </a:p>
+        </p:txBody>
+      </p:sp>
+      <p:sp>
+        <p:nvSpPr>
+          <p:cNvPr id="25" name="Slide Number Placeholder 0"/>
+          <p:cNvSpPr>
+            <a:spLocks noGrp="1"/>
+          </p:cNvSpPr>
+          <p:nvPr>
+            <p:ph type="sldNum" sz="quarter" idx="4294967295"/>
+          </p:nvPr>
+        </p:nvSpPr>
+        <p:spPr>
+          <a:xfrm>
+            <a:off x="11430000" y="6510528"/>
+            <a:ext cx="548640" cy="274320"/>
+          </a:xfrm>
+          <a:prstGeom prst="rect">
+            <a:avLst/>
+          </a:prstGeom>
+          <a:extLst>
+            <a:ext uri="{C572A759-6A51-4108-AA02-DFA0A04FC94B}">
+              <ma14:wrappingTextBoxFlag xmlns:ma14="http://schemas.microsoft.com/office/mac/drawingml/2011/main" val="0"/>
+            </a:ext>
+          </a:extLst>
+        </p:spPr>
+        <p:txBody>
+          <a:bodyPr/>
+          <a:lstStyle>
+            <a:lvl1pPr>
+              <a:defRPr sz="1000">
+                <a:solidFill>
+                  <a:srgbClr val="8A93A3"/>
+                </a:solidFill>
+                <a:latin typeface="Calibri"/>
+                <a:ea typeface="Calibri"/>
+                <a:cs typeface="Calibri"/>
+              </a:defRPr>
+            </a:lvl1pPr>
+          </a:lstStyle>
+          <a:p>
+            <a:pPr algn="r"/>
+            <a:fld id="{F7021451-1387-4CA6-816F-3879F97B5CBC}" type="slidenum">
+              <a:rPr b="0" lang="en-US"/>
+              <a:t>15</a:t>
+            </a:fld>
+            <a:endParaRPr lang="en-US"/>
+          </a:p>
+        </p:txBody>
+      </p:sp>
+    </p:spTree>
+  </p:cSld>
+  <p:clrMapOvr>
+    <a:masterClrMapping/>
+  </p:clrMapOvr>
+</p:sld>
+</file>
+
 <file path=ppt/slides/slide2.xml><?xml version="1.0" encoding="utf-8"?>
 <p:sld xmlns:a="http://schemas.openxmlformats.org/drawingml/2006/main" xmlns:r="http://schemas.openxmlformats.org/officeDocument/2006/relationships" xmlns:p="http://schemas.openxmlformats.org/presentationml/2006/main">
   <p:cSld name="Slide 2">
@@ -8897,7 +9620,7 @@
                 <a:ea typeface="Calibri" pitchFamily="34" charset="-122"/>
                 <a:cs typeface="Calibri" pitchFamily="34" charset="-120"/>
               </a:rPr>
-              <a:t>API REST, 19 endpoints</a:t>
+              <a:t>API REST, 25 endpoints</a:t>
             </a:r>
             <a:endParaRPr lang="en-US" sz="1300" dirty="0"/>
           </a:p>
@@ -11434,7 +12157,7 @@
                 <a:ea typeface="Calibri" pitchFamily="34" charset="-122"/>
                 <a:cs typeface="Calibri" pitchFamily="34" charset="-120"/>
               </a:rPr>
-              <a:t>Cualquier celular en red, escaneando el QR, abre directo la trazabilidad — sin tipear nada.</a:t>
+              <a:t>Un celular en la misma red y con sesión iniciada, escaneando el QR, abre directo la trazabilidad — sin tipear nada.</a:t>
             </a:r>
             <a:endParaRPr lang="en-US" sz="1200" dirty="0"/>
           </a:p>
@@ -12824,7 +13547,7 @@
                 <a:ea typeface="Calibri" pitchFamily="34" charset="-122"/>
                 <a:cs typeface="Calibri" pitchFamily="34" charset="-120"/>
               </a:rPr>
-              <a:t>Proveedor: crear / editar / baja</a:t>
+              <a:t>Proveedor: crear / editar / baja (solo API)</a:t>
             </a:r>
             <a:endParaRPr lang="en-US" sz="1300" dirty="0"/>
           </a:p>

</xml_diff>